<commit_message>
fix: align submission evidence and hosted contract discovery
</commit_message>
<xml_diff>
--- a/submission/Aletheia_Midnight_Buildathon_Wave1.pptx
+++ b/submission/Aletheia_Midnight_Buildathon_Wave1.pptx
@@ -2,20 +2,20 @@
 <file path=ppt/presentation.xml><?xml version="1.0" encoding="utf-8"?>
 <p:presentation xmlns:p="http://schemas.openxmlformats.org/presentationml/2006/main">
   <p:sldMasterIdLst>
-    <p:sldMasterId xmlns:r="http://schemas.openxmlformats.org/officeDocument/2006/relationships" id="2147483648" r:id="Rc3f805366848438e"/>
+    <p:sldMasterId xmlns:r="http://schemas.openxmlformats.org/officeDocument/2006/relationships" id="2147483648" r:id="R5964038e06cd4fac"/>
   </p:sldMasterIdLst>
   <p:notesMasterIdLst>
-    <p:notesMasterId xmlns:r="http://schemas.openxmlformats.org/officeDocument/2006/relationships" r:id="R5762d8e7d61b46fb"/>
+    <p:notesMasterId xmlns:r="http://schemas.openxmlformats.org/officeDocument/2006/relationships" r:id="R86d7650d2ed040ba"/>
   </p:notesMasterIdLst>
   <p:sldIdLst>
-    <p:sldId xmlns:r="http://schemas.openxmlformats.org/officeDocument/2006/relationships" id="256" r:id="Ra54f7f3c37f44e3d"/>
-    <p:sldId xmlns:r="http://schemas.openxmlformats.org/officeDocument/2006/relationships" id="257" r:id="R739a0b4936644bf5"/>
-    <p:sldId xmlns:r="http://schemas.openxmlformats.org/officeDocument/2006/relationships" id="258" r:id="R2825fd27275843b1"/>
-    <p:sldId xmlns:r="http://schemas.openxmlformats.org/officeDocument/2006/relationships" id="259" r:id="R503b0cbf944a4301"/>
-    <p:sldId xmlns:r="http://schemas.openxmlformats.org/officeDocument/2006/relationships" id="260" r:id="Rb52969d5ca584346"/>
-    <p:sldId xmlns:r="http://schemas.openxmlformats.org/officeDocument/2006/relationships" id="261" r:id="R6f6572943ac14bf5"/>
-    <p:sldId xmlns:r="http://schemas.openxmlformats.org/officeDocument/2006/relationships" id="262" r:id="R853ce3e46fca47e9"/>
-    <p:sldId xmlns:r="http://schemas.openxmlformats.org/officeDocument/2006/relationships" id="263" r:id="Re63436bdfc784bcb"/>
+    <p:sldId xmlns:r="http://schemas.openxmlformats.org/officeDocument/2006/relationships" id="256" r:id="Reddcbead0dfd417c"/>
+    <p:sldId xmlns:r="http://schemas.openxmlformats.org/officeDocument/2006/relationships" id="257" r:id="Rf260084b59ff4340"/>
+    <p:sldId xmlns:r="http://schemas.openxmlformats.org/officeDocument/2006/relationships" id="258" r:id="Rbba4a25a3a824705"/>
+    <p:sldId xmlns:r="http://schemas.openxmlformats.org/officeDocument/2006/relationships" id="259" r:id="R198c930fcce1414a"/>
+    <p:sldId xmlns:r="http://schemas.openxmlformats.org/officeDocument/2006/relationships" id="260" r:id="R3e9ad08feae74a5e"/>
+    <p:sldId xmlns:r="http://schemas.openxmlformats.org/officeDocument/2006/relationships" id="261" r:id="R6ed2d2140fdf473e"/>
+    <p:sldId xmlns:r="http://schemas.openxmlformats.org/officeDocument/2006/relationships" id="262" r:id="R015c5c5fa83441d4"/>
+    <p:sldId xmlns:r="http://schemas.openxmlformats.org/officeDocument/2006/relationships" id="263" r:id="R26ccd537ed614c5b"/>
   </p:sldIdLst>
   <p:sldSz cx="12192000" cy="6858000"/>
   <p:notesSz cx="6858000" cy="9144000"/>
@@ -472,6 +472,81 @@
               <a:t>- https://api.akindo.io/public/wave-hacks/jaMZjqPOBsLXvjdG</a:t>
             </a:r>
           </a:p>
+          <a:p xmlns:a="http://schemas.openxmlformats.org/drawingml/2006/main">
+            <a:r>
+              <a:t/>
+            </a:r>
+          </a:p>
+          <a:p xmlns:a="http://schemas.openxmlformats.org/drawingml/2006/main">
+            <a:r>
+              <a:t>Correction 2026-09-05: Inventory caps and receipts are backend operations, not checks in the deployed Compact claim circuit. The demo issuer accepts new commitments; duplicate rejection is for the same secret and program. Wallet, issuer and network metadata can still correlate activity. Remote proof providers may receive witnesses.</a:t>
+            </a:r>
+          </a:p>
+          <a:p xmlns:a="http://schemas.openxmlformats.org/drawingml/2006/main">
+            <a:r>
+              <a:t/>
+            </a:r>
+          </a:p>
+          <a:p xmlns:a="http://schemas.openxmlformats.org/drawingml/2006/main">
+            <a:r>
+              <a:t>Verified release: main merge 0b76d57; 57 application tests plus 7 compiled-contract tests. Production dependency audit found zero known advisories on 2026-09-04. This is not an independent security audit.</a:t>
+            </a:r>
+          </a:p>
+          <a:p xmlns:a="http://schemas.openxmlformats.org/drawingml/2006/main">
+            <a:r>
+              <a:t/>
+            </a:r>
+          </a:p>
+          <a:p xmlns:a="http://schemas.openxmlformats.org/drawingml/2006/main">
+            <a:r>
+              <a:t>Operational contract: 7e4e3c18a2a139711f17085aef0aa66c953fa901900ab66895c9a26cca257fa5</a:t>
+            </a:r>
+          </a:p>
+          <a:p xmlns:a="http://schemas.openxmlformats.org/drawingml/2006/main">
+            <a:r>
+              <a:t/>
+            </a:r>
+          </a:p>
+          <a:p xmlns:a="http://schemas.openxmlformats.org/drawingml/2006/main">
+            <a:r>
+              <a:t>Claim transaction: 75d2978454c959f71f71b200177a865aec9a31ee316580ac5bb0df1abddad88a; identifier 00717e8efcb983c2cf45dcd0d763690ce7a70aa9b133aa370d8d06cfbd0a01fddd; block 2391682. The standalone transaction does not finalize backend inventory. Additional public duplicate and cross-program captures are pending.</a:t>
+            </a:r>
+          </a:p>
+          <a:p xmlns:a="http://schemas.openxmlformats.org/drawingml/2006/main">
+            <a:r>
+              <a:t/>
+            </a:r>
+          </a:p>
+          <a:p xmlns:a="http://schemas.openxmlformats.org/drawingml/2006/main">
+            <a:r>
+              <a:t>[Sources]</a:t>
+            </a:r>
+          </a:p>
+          <a:p xmlns:a="http://schemas.openxmlformats.org/drawingml/2006/main">
+            <a:r>
+              <a:t>https://github.com/0xNexuz/aletheia/blob/main/evidence/claim-preprod-food-support.json</a:t>
+            </a:r>
+          </a:p>
+          <a:p xmlns:a="http://schemas.openxmlformats.org/drawingml/2006/main">
+            <a:r>
+              <a:t>https://github.com/0xNexuz/aletheia/blob/main/contract/src/aletheia.compact</a:t>
+            </a:r>
+          </a:p>
+          <a:p xmlns:a="http://schemas.openxmlformats.org/drawingml/2006/main">
+            <a:r>
+              <a:t>https://github.com/0xNexuz/aletheia/blob/main/PRIVACY.md</a:t>
+            </a:r>
+          </a:p>
+          <a:p xmlns:a="http://schemas.openxmlformats.org/drawingml/2006/main">
+            <a:r>
+              <a:t>https://github.com/0xNexuz/aletheia/blob/main/WAVE1_PROGRESS.md</a:t>
+            </a:r>
+          </a:p>
+          <a:p xmlns:a="http://schemas.openxmlformats.org/drawingml/2006/main">
+            <a:r>
+              <a:t>https://alethia-pi.vercel.app</a:t>
+            </a:r>
+          </a:p>
         </p:txBody>
       </p:sp>
       <p:sp>
@@ -557,6 +632,81 @@
               <a:t>- https://github.com/0xNexuz/aletheia/blob/main/PRIVACY.md</a:t>
             </a:r>
           </a:p>
+          <a:p xmlns:a="http://schemas.openxmlformats.org/drawingml/2006/main">
+            <a:r>
+              <a:t/>
+            </a:r>
+          </a:p>
+          <a:p xmlns:a="http://schemas.openxmlformats.org/drawingml/2006/main">
+            <a:r>
+              <a:t>Correction 2026-09-05: Inventory caps and receipts are backend operations, not checks in the deployed Compact claim circuit. The demo issuer accepts new commitments; duplicate rejection is for the same secret and program. Wallet, issuer and network metadata can still correlate activity. Remote proof providers may receive witnesses.</a:t>
+            </a:r>
+          </a:p>
+          <a:p xmlns:a="http://schemas.openxmlformats.org/drawingml/2006/main">
+            <a:r>
+              <a:t/>
+            </a:r>
+          </a:p>
+          <a:p xmlns:a="http://schemas.openxmlformats.org/drawingml/2006/main">
+            <a:r>
+              <a:t>Verified release: main merge 0b76d57; 57 application tests plus 7 compiled-contract tests. Production dependency audit found zero known advisories on 2026-09-04. This is not an independent security audit.</a:t>
+            </a:r>
+          </a:p>
+          <a:p xmlns:a="http://schemas.openxmlformats.org/drawingml/2006/main">
+            <a:r>
+              <a:t/>
+            </a:r>
+          </a:p>
+          <a:p xmlns:a="http://schemas.openxmlformats.org/drawingml/2006/main">
+            <a:r>
+              <a:t>Operational contract: 7e4e3c18a2a139711f17085aef0aa66c953fa901900ab66895c9a26cca257fa5</a:t>
+            </a:r>
+          </a:p>
+          <a:p xmlns:a="http://schemas.openxmlformats.org/drawingml/2006/main">
+            <a:r>
+              <a:t/>
+            </a:r>
+          </a:p>
+          <a:p xmlns:a="http://schemas.openxmlformats.org/drawingml/2006/main">
+            <a:r>
+              <a:t>Claim transaction: 75d2978454c959f71f71b200177a865aec9a31ee316580ac5bb0df1abddad88a; identifier 00717e8efcb983c2cf45dcd0d763690ce7a70aa9b133aa370d8d06cfbd0a01fddd; block 2391682. The standalone transaction does not finalize backend inventory. Additional public duplicate and cross-program captures are pending.</a:t>
+            </a:r>
+          </a:p>
+          <a:p xmlns:a="http://schemas.openxmlformats.org/drawingml/2006/main">
+            <a:r>
+              <a:t/>
+            </a:r>
+          </a:p>
+          <a:p xmlns:a="http://schemas.openxmlformats.org/drawingml/2006/main">
+            <a:r>
+              <a:t>[Sources]</a:t>
+            </a:r>
+          </a:p>
+          <a:p xmlns:a="http://schemas.openxmlformats.org/drawingml/2006/main">
+            <a:r>
+              <a:t>https://github.com/0xNexuz/aletheia/blob/main/evidence/claim-preprod-food-support.json</a:t>
+            </a:r>
+          </a:p>
+          <a:p xmlns:a="http://schemas.openxmlformats.org/drawingml/2006/main">
+            <a:r>
+              <a:t>https://github.com/0xNexuz/aletheia/blob/main/contract/src/aletheia.compact</a:t>
+            </a:r>
+          </a:p>
+          <a:p xmlns:a="http://schemas.openxmlformats.org/drawingml/2006/main">
+            <a:r>
+              <a:t>https://github.com/0xNexuz/aletheia/blob/main/PRIVACY.md</a:t>
+            </a:r>
+          </a:p>
+          <a:p xmlns:a="http://schemas.openxmlformats.org/drawingml/2006/main">
+            <a:r>
+              <a:t>https://github.com/0xNexuz/aletheia/blob/main/WAVE1_PROGRESS.md</a:t>
+            </a:r>
+          </a:p>
+          <a:p xmlns:a="http://schemas.openxmlformats.org/drawingml/2006/main">
+            <a:r>
+              <a:t>https://alethia-pi.vercel.app</a:t>
+            </a:r>
+          </a:p>
         </p:txBody>
       </p:sp>
       <p:sp>
@@ -647,6 +797,81 @@
               <a:t>- https://github.com/0xNexuz/aletheia/blob/main/ARCHITECTURE.md</a:t>
             </a:r>
           </a:p>
+          <a:p xmlns:a="http://schemas.openxmlformats.org/drawingml/2006/main">
+            <a:r>
+              <a:t/>
+            </a:r>
+          </a:p>
+          <a:p xmlns:a="http://schemas.openxmlformats.org/drawingml/2006/main">
+            <a:r>
+              <a:t>Correction 2026-09-05: Inventory caps and receipts are backend operations, not checks in the deployed Compact claim circuit. The demo issuer accepts new commitments; duplicate rejection is for the same secret and program. Wallet, issuer and network metadata can still correlate activity. Remote proof providers may receive witnesses.</a:t>
+            </a:r>
+          </a:p>
+          <a:p xmlns:a="http://schemas.openxmlformats.org/drawingml/2006/main">
+            <a:r>
+              <a:t/>
+            </a:r>
+          </a:p>
+          <a:p xmlns:a="http://schemas.openxmlformats.org/drawingml/2006/main">
+            <a:r>
+              <a:t>Verified release: main merge 0b76d57; 57 application tests plus 7 compiled-contract tests. Production dependency audit found zero known advisories on 2026-09-04. This is not an independent security audit.</a:t>
+            </a:r>
+          </a:p>
+          <a:p xmlns:a="http://schemas.openxmlformats.org/drawingml/2006/main">
+            <a:r>
+              <a:t/>
+            </a:r>
+          </a:p>
+          <a:p xmlns:a="http://schemas.openxmlformats.org/drawingml/2006/main">
+            <a:r>
+              <a:t>Operational contract: 7e4e3c18a2a139711f17085aef0aa66c953fa901900ab66895c9a26cca257fa5</a:t>
+            </a:r>
+          </a:p>
+          <a:p xmlns:a="http://schemas.openxmlformats.org/drawingml/2006/main">
+            <a:r>
+              <a:t/>
+            </a:r>
+          </a:p>
+          <a:p xmlns:a="http://schemas.openxmlformats.org/drawingml/2006/main">
+            <a:r>
+              <a:t>Claim transaction: 75d2978454c959f71f71b200177a865aec9a31ee316580ac5bb0df1abddad88a; identifier 00717e8efcb983c2cf45dcd0d763690ce7a70aa9b133aa370d8d06cfbd0a01fddd; block 2391682. The standalone transaction does not finalize backend inventory. Additional public duplicate and cross-program captures are pending.</a:t>
+            </a:r>
+          </a:p>
+          <a:p xmlns:a="http://schemas.openxmlformats.org/drawingml/2006/main">
+            <a:r>
+              <a:t/>
+            </a:r>
+          </a:p>
+          <a:p xmlns:a="http://schemas.openxmlformats.org/drawingml/2006/main">
+            <a:r>
+              <a:t>[Sources]</a:t>
+            </a:r>
+          </a:p>
+          <a:p xmlns:a="http://schemas.openxmlformats.org/drawingml/2006/main">
+            <a:r>
+              <a:t>https://github.com/0xNexuz/aletheia/blob/main/evidence/claim-preprod-food-support.json</a:t>
+            </a:r>
+          </a:p>
+          <a:p xmlns:a="http://schemas.openxmlformats.org/drawingml/2006/main">
+            <a:r>
+              <a:t>https://github.com/0xNexuz/aletheia/blob/main/contract/src/aletheia.compact</a:t>
+            </a:r>
+          </a:p>
+          <a:p xmlns:a="http://schemas.openxmlformats.org/drawingml/2006/main">
+            <a:r>
+              <a:t>https://github.com/0xNexuz/aletheia/blob/main/PRIVACY.md</a:t>
+            </a:r>
+          </a:p>
+          <a:p xmlns:a="http://schemas.openxmlformats.org/drawingml/2006/main">
+            <a:r>
+              <a:t>https://github.com/0xNexuz/aletheia/blob/main/WAVE1_PROGRESS.md</a:t>
+            </a:r>
+          </a:p>
+          <a:p xmlns:a="http://schemas.openxmlformats.org/drawingml/2006/main">
+            <a:r>
+              <a:t>https://alethia-pi.vercel.app</a:t>
+            </a:r>
+          </a:p>
         </p:txBody>
       </p:sp>
       <p:sp>
@@ -737,6 +962,81 @@
               <a:t>- https://github.com/0xNexuz/aletheia/blob/main/tests/privacy-contract.test.mjs</a:t>
             </a:r>
           </a:p>
+          <a:p xmlns:a="http://schemas.openxmlformats.org/drawingml/2006/main">
+            <a:r>
+              <a:t/>
+            </a:r>
+          </a:p>
+          <a:p xmlns:a="http://schemas.openxmlformats.org/drawingml/2006/main">
+            <a:r>
+              <a:t>Correction 2026-09-05: Inventory caps and receipts are backend operations, not checks in the deployed Compact claim circuit. The demo issuer accepts new commitments; duplicate rejection is for the same secret and program. Wallet, issuer and network metadata can still correlate activity. Remote proof providers may receive witnesses.</a:t>
+            </a:r>
+          </a:p>
+          <a:p xmlns:a="http://schemas.openxmlformats.org/drawingml/2006/main">
+            <a:r>
+              <a:t/>
+            </a:r>
+          </a:p>
+          <a:p xmlns:a="http://schemas.openxmlformats.org/drawingml/2006/main">
+            <a:r>
+              <a:t>Verified release: main merge 0b76d57; 57 application tests plus 7 compiled-contract tests. Production dependency audit found zero known advisories on 2026-09-04. This is not an independent security audit.</a:t>
+            </a:r>
+          </a:p>
+          <a:p xmlns:a="http://schemas.openxmlformats.org/drawingml/2006/main">
+            <a:r>
+              <a:t/>
+            </a:r>
+          </a:p>
+          <a:p xmlns:a="http://schemas.openxmlformats.org/drawingml/2006/main">
+            <a:r>
+              <a:t>Operational contract: 7e4e3c18a2a139711f17085aef0aa66c953fa901900ab66895c9a26cca257fa5</a:t>
+            </a:r>
+          </a:p>
+          <a:p xmlns:a="http://schemas.openxmlformats.org/drawingml/2006/main">
+            <a:r>
+              <a:t/>
+            </a:r>
+          </a:p>
+          <a:p xmlns:a="http://schemas.openxmlformats.org/drawingml/2006/main">
+            <a:r>
+              <a:t>Claim transaction: 75d2978454c959f71f71b200177a865aec9a31ee316580ac5bb0df1abddad88a; identifier 00717e8efcb983c2cf45dcd0d763690ce7a70aa9b133aa370d8d06cfbd0a01fddd; block 2391682. The standalone transaction does not finalize backend inventory. Additional public duplicate and cross-program captures are pending.</a:t>
+            </a:r>
+          </a:p>
+          <a:p xmlns:a="http://schemas.openxmlformats.org/drawingml/2006/main">
+            <a:r>
+              <a:t/>
+            </a:r>
+          </a:p>
+          <a:p xmlns:a="http://schemas.openxmlformats.org/drawingml/2006/main">
+            <a:r>
+              <a:t>[Sources]</a:t>
+            </a:r>
+          </a:p>
+          <a:p xmlns:a="http://schemas.openxmlformats.org/drawingml/2006/main">
+            <a:r>
+              <a:t>https://github.com/0xNexuz/aletheia/blob/main/evidence/claim-preprod-food-support.json</a:t>
+            </a:r>
+          </a:p>
+          <a:p xmlns:a="http://schemas.openxmlformats.org/drawingml/2006/main">
+            <a:r>
+              <a:t>https://github.com/0xNexuz/aletheia/blob/main/contract/src/aletheia.compact</a:t>
+            </a:r>
+          </a:p>
+          <a:p xmlns:a="http://schemas.openxmlformats.org/drawingml/2006/main">
+            <a:r>
+              <a:t>https://github.com/0xNexuz/aletheia/blob/main/PRIVACY.md</a:t>
+            </a:r>
+          </a:p>
+          <a:p xmlns:a="http://schemas.openxmlformats.org/drawingml/2006/main">
+            <a:r>
+              <a:t>https://github.com/0xNexuz/aletheia/blob/main/WAVE1_PROGRESS.md</a:t>
+            </a:r>
+          </a:p>
+          <a:p xmlns:a="http://schemas.openxmlformats.org/drawingml/2006/main">
+            <a:r>
+              <a:t>https://alethia-pi.vercel.app</a:t>
+            </a:r>
+          </a:p>
         </p:txBody>
       </p:sp>
       <p:sp>
@@ -804,7 +1104,7 @@
           <a:lstStyle xmlns:a="http://schemas.openxmlformats.org/drawingml/2006/main"/>
           <a:p xmlns:a="http://schemas.openxmlformats.org/drawingml/2006/main">
             <a:r>
-              <a:t>Keep the live demo short. The strongest sequence is success, same-program duplicate rejection, then a different program-scoped nullifier.</a:t>
+              <a:t>Correction 2026-09-05: Inventory caps and receipts are backend operations, not checks in the deployed Compact claim circuit. The demo issuer accepts new commitments; duplicate rejection is for the same secret and program. Wallet, issuer and network metadata can still correlate activity. Remote proof providers may receive witnesses.</a:t>
             </a:r>
           </a:p>
           <a:p xmlns:a="http://schemas.openxmlformats.org/drawingml/2006/main">
@@ -814,17 +1114,62 @@
           </a:p>
           <a:p xmlns:a="http://schemas.openxmlformats.org/drawingml/2006/main">
             <a:r>
+              <a:t>Verified release: main merge 0b76d57; 57 application tests plus 7 compiled-contract tests. Production dependency audit found zero known advisories on 2026-09-04. This is not an independent security audit.</a:t>
+            </a:r>
+          </a:p>
+          <a:p xmlns:a="http://schemas.openxmlformats.org/drawingml/2006/main">
+            <a:r>
+              <a:t/>
+            </a:r>
+          </a:p>
+          <a:p xmlns:a="http://schemas.openxmlformats.org/drawingml/2006/main">
+            <a:r>
+              <a:t>Operational contract: 7e4e3c18a2a139711f17085aef0aa66c953fa901900ab66895c9a26cca257fa5</a:t>
+            </a:r>
+          </a:p>
+          <a:p xmlns:a="http://schemas.openxmlformats.org/drawingml/2006/main">
+            <a:r>
+              <a:t/>
+            </a:r>
+          </a:p>
+          <a:p xmlns:a="http://schemas.openxmlformats.org/drawingml/2006/main">
+            <a:r>
+              <a:t>Claim transaction: 75d2978454c959f71f71b200177a865aec9a31ee316580ac5bb0df1abddad88a; identifier 00717e8efcb983c2cf45dcd0d763690ce7a70aa9b133aa370d8d06cfbd0a01fddd; block 2391682. The standalone transaction does not finalize backend inventory. Additional public duplicate and cross-program captures are pending.</a:t>
+            </a:r>
+          </a:p>
+          <a:p xmlns:a="http://schemas.openxmlformats.org/drawingml/2006/main">
+            <a:r>
+              <a:t/>
+            </a:r>
+          </a:p>
+          <a:p xmlns:a="http://schemas.openxmlformats.org/drawingml/2006/main">
+            <a:r>
               <a:t>[Sources]</a:t>
             </a:r>
           </a:p>
           <a:p xmlns:a="http://schemas.openxmlformats.org/drawingml/2006/main">
             <a:r>
-              <a:t>- https://alethia-pi.vercel.app</a:t>
-            </a:r>
-          </a:p>
-          <a:p xmlns:a="http://schemas.openxmlformats.org/drawingml/2006/main">
-            <a:r>
-              <a:t>- https://github.com/0xNexuz/aletheia/blob/main/DEMO.md</a:t>
+              <a:t>https://github.com/0xNexuz/aletheia/blob/main/evidence/claim-preprod-food-support.json</a:t>
+            </a:r>
+          </a:p>
+          <a:p xmlns:a="http://schemas.openxmlformats.org/drawingml/2006/main">
+            <a:r>
+              <a:t>https://github.com/0xNexuz/aletheia/blob/main/contract/src/aletheia.compact</a:t>
+            </a:r>
+          </a:p>
+          <a:p xmlns:a="http://schemas.openxmlformats.org/drawingml/2006/main">
+            <a:r>
+              <a:t>https://github.com/0xNexuz/aletheia/blob/main/PRIVACY.md</a:t>
+            </a:r>
+          </a:p>
+          <a:p xmlns:a="http://schemas.openxmlformats.org/drawingml/2006/main">
+            <a:r>
+              <a:t>https://github.com/0xNexuz/aletheia/blob/main/WAVE1_PROGRESS.md</a:t>
+            </a:r>
+          </a:p>
+          <a:p xmlns:a="http://schemas.openxmlformats.org/drawingml/2006/main">
+            <a:r>
+              <a:t>https://alethia-pi.vercel.app</a:t>
             </a:r>
           </a:p>
         </p:txBody>
@@ -917,6 +1262,81 @@
               <a:t>- https://github.com/0xNexuz/aletheia/tree/main/tests</a:t>
             </a:r>
           </a:p>
+          <a:p xmlns:a="http://schemas.openxmlformats.org/drawingml/2006/main">
+            <a:r>
+              <a:t/>
+            </a:r>
+          </a:p>
+          <a:p xmlns:a="http://schemas.openxmlformats.org/drawingml/2006/main">
+            <a:r>
+              <a:t>Correction 2026-09-05: Inventory caps and receipts are backend operations, not checks in the deployed Compact claim circuit. The demo issuer accepts new commitments; duplicate rejection is for the same secret and program. Wallet, issuer and network metadata can still correlate activity. Remote proof providers may receive witnesses.</a:t>
+            </a:r>
+          </a:p>
+          <a:p xmlns:a="http://schemas.openxmlformats.org/drawingml/2006/main">
+            <a:r>
+              <a:t/>
+            </a:r>
+          </a:p>
+          <a:p xmlns:a="http://schemas.openxmlformats.org/drawingml/2006/main">
+            <a:r>
+              <a:t>Verified release: main merge 0b76d57; 57 application tests plus 7 compiled-contract tests. Production dependency audit found zero known advisories on 2026-09-04. This is not an independent security audit.</a:t>
+            </a:r>
+          </a:p>
+          <a:p xmlns:a="http://schemas.openxmlformats.org/drawingml/2006/main">
+            <a:r>
+              <a:t/>
+            </a:r>
+          </a:p>
+          <a:p xmlns:a="http://schemas.openxmlformats.org/drawingml/2006/main">
+            <a:r>
+              <a:t>Operational contract: 7e4e3c18a2a139711f17085aef0aa66c953fa901900ab66895c9a26cca257fa5</a:t>
+            </a:r>
+          </a:p>
+          <a:p xmlns:a="http://schemas.openxmlformats.org/drawingml/2006/main">
+            <a:r>
+              <a:t/>
+            </a:r>
+          </a:p>
+          <a:p xmlns:a="http://schemas.openxmlformats.org/drawingml/2006/main">
+            <a:r>
+              <a:t>Claim transaction: 75d2978454c959f71f71b200177a865aec9a31ee316580ac5bb0df1abddad88a; identifier 00717e8efcb983c2cf45dcd0d763690ce7a70aa9b133aa370d8d06cfbd0a01fddd; block 2391682. The standalone transaction does not finalize backend inventory. Additional public duplicate and cross-program captures are pending.</a:t>
+            </a:r>
+          </a:p>
+          <a:p xmlns:a="http://schemas.openxmlformats.org/drawingml/2006/main">
+            <a:r>
+              <a:t/>
+            </a:r>
+          </a:p>
+          <a:p xmlns:a="http://schemas.openxmlformats.org/drawingml/2006/main">
+            <a:r>
+              <a:t>[Sources]</a:t>
+            </a:r>
+          </a:p>
+          <a:p xmlns:a="http://schemas.openxmlformats.org/drawingml/2006/main">
+            <a:r>
+              <a:t>https://github.com/0xNexuz/aletheia/blob/main/evidence/claim-preprod-food-support.json</a:t>
+            </a:r>
+          </a:p>
+          <a:p xmlns:a="http://schemas.openxmlformats.org/drawingml/2006/main">
+            <a:r>
+              <a:t>https://github.com/0xNexuz/aletheia/blob/main/contract/src/aletheia.compact</a:t>
+            </a:r>
+          </a:p>
+          <a:p xmlns:a="http://schemas.openxmlformats.org/drawingml/2006/main">
+            <a:r>
+              <a:t>https://github.com/0xNexuz/aletheia/blob/main/PRIVACY.md</a:t>
+            </a:r>
+          </a:p>
+          <a:p xmlns:a="http://schemas.openxmlformats.org/drawingml/2006/main">
+            <a:r>
+              <a:t>https://github.com/0xNexuz/aletheia/blob/main/WAVE1_PROGRESS.md</a:t>
+            </a:r>
+          </a:p>
+          <a:p xmlns:a="http://schemas.openxmlformats.org/drawingml/2006/main">
+            <a:r>
+              <a:t>https://alethia-pi.vercel.app</a:t>
+            </a:r>
+          </a:p>
         </p:txBody>
       </p:sp>
       <p:sp>
@@ -984,7 +1404,7 @@
           <a:lstStyle xmlns:a="http://schemas.openxmlformats.org/drawingml/2006/main"/>
           <a:p xmlns:a="http://schemas.openxmlformats.org/drawingml/2006/main">
             <a:r>
-              <a:t>Be direct about the remaining gate. Credibility is stronger than presenting simulation as deployment.</a:t>
+              <a:t>Correction 2026-09-05: Inventory caps and receipts are backend operations, not checks in the deployed Compact claim circuit. The demo issuer accepts new commitments; duplicate rejection is for the same secret and program. Wallet, issuer and network metadata can still correlate activity. Remote proof providers may receive witnesses.</a:t>
             </a:r>
           </a:p>
           <a:p xmlns:a="http://schemas.openxmlformats.org/drawingml/2006/main">
@@ -994,17 +1414,62 @@
           </a:p>
           <a:p xmlns:a="http://schemas.openxmlformats.org/drawingml/2006/main">
             <a:r>
+              <a:t>Verified release: main merge 0b76d57; 57 application tests plus 7 compiled-contract tests. Production dependency audit found zero known advisories on 2026-09-04. This is not an independent security audit.</a:t>
+            </a:r>
+          </a:p>
+          <a:p xmlns:a="http://schemas.openxmlformats.org/drawingml/2006/main">
+            <a:r>
+              <a:t/>
+            </a:r>
+          </a:p>
+          <a:p xmlns:a="http://schemas.openxmlformats.org/drawingml/2006/main">
+            <a:r>
+              <a:t>Operational contract: 7e4e3c18a2a139711f17085aef0aa66c953fa901900ab66895c9a26cca257fa5</a:t>
+            </a:r>
+          </a:p>
+          <a:p xmlns:a="http://schemas.openxmlformats.org/drawingml/2006/main">
+            <a:r>
+              <a:t/>
+            </a:r>
+          </a:p>
+          <a:p xmlns:a="http://schemas.openxmlformats.org/drawingml/2006/main">
+            <a:r>
+              <a:t>Claim transaction: 75d2978454c959f71f71b200177a865aec9a31ee316580ac5bb0df1abddad88a; identifier 00717e8efcb983c2cf45dcd0d763690ce7a70aa9b133aa370d8d06cfbd0a01fddd; block 2391682. The standalone transaction does not finalize backend inventory. Additional public duplicate and cross-program captures are pending.</a:t>
+            </a:r>
+          </a:p>
+          <a:p xmlns:a="http://schemas.openxmlformats.org/drawingml/2006/main">
+            <a:r>
+              <a:t/>
+            </a:r>
+          </a:p>
+          <a:p xmlns:a="http://schemas.openxmlformats.org/drawingml/2006/main">
+            <a:r>
               <a:t>[Sources]</a:t>
             </a:r>
           </a:p>
           <a:p xmlns:a="http://schemas.openxmlformats.org/drawingml/2006/main">
             <a:r>
-              <a:t>- https://github.com/0xNexuz/aletheia/blob/main/README.md</a:t>
-            </a:r>
-          </a:p>
-          <a:p xmlns:a="http://schemas.openxmlformats.org/drawingml/2006/main">
-            <a:r>
-              <a:t>- https://github.com/0xNexuz/aletheia/blob/main/WAVE1_PROGRESS.md</a:t>
+              <a:t>https://github.com/0xNexuz/aletheia/blob/main/evidence/claim-preprod-food-support.json</a:t>
+            </a:r>
+          </a:p>
+          <a:p xmlns:a="http://schemas.openxmlformats.org/drawingml/2006/main">
+            <a:r>
+              <a:t>https://github.com/0xNexuz/aletheia/blob/main/contract/src/aletheia.compact</a:t>
+            </a:r>
+          </a:p>
+          <a:p xmlns:a="http://schemas.openxmlformats.org/drawingml/2006/main">
+            <a:r>
+              <a:t>https://github.com/0xNexuz/aletheia/blob/main/PRIVACY.md</a:t>
+            </a:r>
+          </a:p>
+          <a:p xmlns:a="http://schemas.openxmlformats.org/drawingml/2006/main">
+            <a:r>
+              <a:t>https://github.com/0xNexuz/aletheia/blob/main/WAVE1_PROGRESS.md</a:t>
+            </a:r>
+          </a:p>
+          <a:p xmlns:a="http://schemas.openxmlformats.org/drawingml/2006/main">
+            <a:r>
+              <a:t>https://alethia-pi.vercel.app</a:t>
             </a:r>
           </a:p>
         </p:txBody>
@@ -1095,6 +1560,81 @@
           <a:p xmlns:a="http://schemas.openxmlformats.org/drawingml/2006/main">
             <a:r>
               <a:t>- https://github.com/0xNexuz/aletheia</a:t>
+            </a:r>
+          </a:p>
+          <a:p xmlns:a="http://schemas.openxmlformats.org/drawingml/2006/main">
+            <a:r>
+              <a:t/>
+            </a:r>
+          </a:p>
+          <a:p xmlns:a="http://schemas.openxmlformats.org/drawingml/2006/main">
+            <a:r>
+              <a:t>Correction 2026-09-05: Inventory caps and receipts are backend operations, not checks in the deployed Compact claim circuit. The demo issuer accepts new commitments; duplicate rejection is for the same secret and program. Wallet, issuer and network metadata can still correlate activity. Remote proof providers may receive witnesses.</a:t>
+            </a:r>
+          </a:p>
+          <a:p xmlns:a="http://schemas.openxmlformats.org/drawingml/2006/main">
+            <a:r>
+              <a:t/>
+            </a:r>
+          </a:p>
+          <a:p xmlns:a="http://schemas.openxmlformats.org/drawingml/2006/main">
+            <a:r>
+              <a:t>Verified release: main merge 0b76d57; 57 application tests plus 7 compiled-contract tests. Production dependency audit found zero known advisories on 2026-09-04. This is not an independent security audit.</a:t>
+            </a:r>
+          </a:p>
+          <a:p xmlns:a="http://schemas.openxmlformats.org/drawingml/2006/main">
+            <a:r>
+              <a:t/>
+            </a:r>
+          </a:p>
+          <a:p xmlns:a="http://schemas.openxmlformats.org/drawingml/2006/main">
+            <a:r>
+              <a:t>Operational contract: 7e4e3c18a2a139711f17085aef0aa66c953fa901900ab66895c9a26cca257fa5</a:t>
+            </a:r>
+          </a:p>
+          <a:p xmlns:a="http://schemas.openxmlformats.org/drawingml/2006/main">
+            <a:r>
+              <a:t/>
+            </a:r>
+          </a:p>
+          <a:p xmlns:a="http://schemas.openxmlformats.org/drawingml/2006/main">
+            <a:r>
+              <a:t>Claim transaction: 75d2978454c959f71f71b200177a865aec9a31ee316580ac5bb0df1abddad88a; identifier 00717e8efcb983c2cf45dcd0d763690ce7a70aa9b133aa370d8d06cfbd0a01fddd; block 2391682. The standalone transaction does not finalize backend inventory. Additional public duplicate and cross-program captures are pending.</a:t>
+            </a:r>
+          </a:p>
+          <a:p xmlns:a="http://schemas.openxmlformats.org/drawingml/2006/main">
+            <a:r>
+              <a:t/>
+            </a:r>
+          </a:p>
+          <a:p xmlns:a="http://schemas.openxmlformats.org/drawingml/2006/main">
+            <a:r>
+              <a:t>[Sources]</a:t>
+            </a:r>
+          </a:p>
+          <a:p xmlns:a="http://schemas.openxmlformats.org/drawingml/2006/main">
+            <a:r>
+              <a:t>https://github.com/0xNexuz/aletheia/blob/main/evidence/claim-preprod-food-support.json</a:t>
+            </a:r>
+          </a:p>
+          <a:p xmlns:a="http://schemas.openxmlformats.org/drawingml/2006/main">
+            <a:r>
+              <a:t>https://github.com/0xNexuz/aletheia/blob/main/contract/src/aletheia.compact</a:t>
+            </a:r>
+          </a:p>
+          <a:p xmlns:a="http://schemas.openxmlformats.org/drawingml/2006/main">
+            <a:r>
+              <a:t>https://github.com/0xNexuz/aletheia/blob/main/PRIVACY.md</a:t>
+            </a:r>
+          </a:p>
+          <a:p xmlns:a="http://schemas.openxmlformats.org/drawingml/2006/main">
+            <a:r>
+              <a:t>https://github.com/0xNexuz/aletheia/blob/main/WAVE1_PROGRESS.md</a:t>
+            </a:r>
+          </a:p>
+          <a:p xmlns:a="http://schemas.openxmlformats.org/drawingml/2006/main">
+            <a:r>
+              <a:t>https://alethia-pi.vercel.app</a:t>
             </a:r>
           </a:p>
         </p:txBody>
@@ -1162,7 +1702,7 @@
   </p:cSld>
   <p:clrMap bg1="lt1" tx1="dk1" bg2="lt2" tx2="dk2" accent1="accent1" accent2="accent2" accent3="accent3" accent4="accent4" accent5="accent5" accent6="accent6" hlink="hlink" folHlink="folHlink"/>
   <p:sldLayoutIdLst>
-    <p:sldLayoutId xmlns:r="http://schemas.openxmlformats.org/officeDocument/2006/relationships" id="2147483649" r:id="R0927f32712fb49f0"/>
+    <p:sldLayoutId xmlns:r="http://schemas.openxmlformats.org/officeDocument/2006/relationships" id="2147483649" r:id="R063fb93c815a4b66"/>
   </p:sldLayoutIdLst>
   <p:txStyles>
     <p:titleStyle>
@@ -1776,6 +2316,7 @@
           <a:lstStyle xmlns:a="http://schemas.openxmlformats.org/drawingml/2006/main"/>
           <a:p xmlns:a="http://schemas.openxmlformats.org/drawingml/2006/main">
             <a:pPr algn="l">
+              <a:buNone/>
               <a:defRPr sz="1200" b="1">
                 <a:solidFill>
                   <a:srgbClr val="6257F5"/>
@@ -1834,6 +2375,7 @@
           <a:lstStyle xmlns:a="http://schemas.openxmlformats.org/drawingml/2006/main"/>
           <a:p xmlns:a="http://schemas.openxmlformats.org/drawingml/2006/main">
             <a:pPr algn="l">
+              <a:buNone/>
               <a:defRPr sz="4950" b="1">
                 <a:solidFill>
                   <a:srgbClr val="0B0B12"/>
@@ -1892,6 +2434,7 @@
           <a:lstStyle xmlns:a="http://schemas.openxmlformats.org/drawingml/2006/main"/>
           <a:p xmlns:a="http://schemas.openxmlformats.org/drawingml/2006/main">
             <a:pPr algn="l">
+              <a:buNone/>
               <a:defRPr sz="2550" b="1">
                 <a:solidFill>
                   <a:srgbClr val="6257F5"/>
@@ -1950,6 +2493,7 @@
           <a:lstStyle xmlns:a="http://schemas.openxmlformats.org/drawingml/2006/main"/>
           <a:p xmlns:a="http://schemas.openxmlformats.org/drawingml/2006/main">
             <a:pPr algn="l">
+              <a:buNone/>
               <a:defRPr sz="1875" b="0">
                 <a:solidFill>
                   <a:srgbClr val="5E6270"/>
@@ -1968,7 +2512,7 @@
                 <a:ea typeface="Arial"/>
                 <a:cs typeface="Arial"/>
               </a:rPr>
-              <a:t>Prevent duplicate aid claims and over-allocation without building a public identity database.</a:t>
+              <a:t>Verify private eligibility and prevent repeat claims per claimant secret and aid program.</a:t>
             </a:r>
           </a:p>
         </p:txBody>
@@ -2008,6 +2552,7 @@
           <a:lstStyle xmlns:a="http://schemas.openxmlformats.org/drawingml/2006/main"/>
           <a:p xmlns:a="http://schemas.openxmlformats.org/drawingml/2006/main">
             <a:pPr algn="l">
+              <a:buNone/>
               <a:defRPr sz="1350" b="1">
                 <a:solidFill>
                   <a:srgbClr val="0B0B12"/>
@@ -2033,14 +2578,14 @@
       </p:sp>
       <p:pic>
         <p:nvPicPr>
-          <p:cNvPr id="15" name=""/>
+          <p:cNvPr id="17" name=""/>
           <p:cNvPicPr>
             <a:picLocks xmlns:a="http://schemas.openxmlformats.org/drawingml/2006/main" noChangeAspect="1"/>
           </p:cNvPicPr>
           <p:nvPr/>
         </p:nvPicPr>
         <p:blipFill>
-          <a:blip xmlns:r="http://schemas.openxmlformats.org/officeDocument/2006/relationships" xmlns:a="http://schemas.openxmlformats.org/drawingml/2006/main" r:embed="R547b0f828e794c18"/>
+          <a:blip xmlns:r="http://schemas.openxmlformats.org/officeDocument/2006/relationships" xmlns:a="http://schemas.openxmlformats.org/drawingml/2006/main" r:embed="R839de441f72944fd"/>
           <a:stretch xmlns:a="http://schemas.openxmlformats.org/drawingml/2006/main"/>
         </p:blipFill>
         <p:spPr>
@@ -2088,6 +2633,7 @@
           <a:lstStyle xmlns:a="http://schemas.openxmlformats.org/drawingml/2006/main"/>
           <a:p xmlns:a="http://schemas.openxmlformats.org/drawingml/2006/main">
             <a:pPr algn="r">
+              <a:buNone/>
               <a:defRPr sz="975" b="0">
                 <a:solidFill>
                   <a:srgbClr val="5E6270"/>
@@ -2175,6 +2721,7 @@
           <a:lstStyle xmlns:a="http://schemas.openxmlformats.org/drawingml/2006/main"/>
           <a:p xmlns:a="http://schemas.openxmlformats.org/drawingml/2006/main">
             <a:pPr algn="l">
+              <a:buNone/>
               <a:defRPr sz="1125" b="1">
                 <a:solidFill>
                   <a:srgbClr val="6257F5"/>
@@ -2233,6 +2780,7 @@
           <a:lstStyle xmlns:a="http://schemas.openxmlformats.org/drawingml/2006/main"/>
           <a:p xmlns:a="http://schemas.openxmlformats.org/drawingml/2006/main">
             <a:pPr algn="l">
+              <a:buNone/>
               <a:defRPr sz="3150" b="1">
                 <a:solidFill>
                   <a:srgbClr val="0B0B12"/>
@@ -2291,6 +2839,7 @@
           <a:lstStyle xmlns:a="http://schemas.openxmlformats.org/drawingml/2006/main"/>
           <a:p xmlns:a="http://schemas.openxmlformats.org/drawingml/2006/main">
             <a:pPr algn="r">
+              <a:buNone/>
               <a:defRPr sz="975" b="0">
                 <a:solidFill>
                   <a:srgbClr val="5E6270"/>
@@ -2349,6 +2898,7 @@
           <a:lstStyle xmlns:a="http://schemas.openxmlformats.org/drawingml/2006/main"/>
           <a:p xmlns:a="http://schemas.openxmlformats.org/drawingml/2006/main">
             <a:pPr algn="l">
+              <a:buNone/>
               <a:defRPr sz="1800" b="0">
                 <a:solidFill>
                   <a:srgbClr val="5E6270"/>
@@ -2407,6 +2957,7 @@
           <a:lstStyle xmlns:a="http://schemas.openxmlformats.org/drawingml/2006/main"/>
           <a:p xmlns:a="http://schemas.openxmlformats.org/drawingml/2006/main">
             <a:pPr algn="l">
+              <a:buNone/>
               <a:defRPr sz="4050" b="1">
                 <a:solidFill>
                   <a:srgbClr val="6257F5"/>
@@ -2460,11 +3011,12 @@
         </p:spPr>
         <p:txBody>
           <a:bodyPr xmlns:a="http://schemas.openxmlformats.org/drawingml/2006/main" anchor="t">
-            <a:normAutofit fontScale="92218"/>
+            <a:normAutofit fontScale="91126"/>
           </a:bodyPr>
           <a:lstStyle xmlns:a="http://schemas.openxmlformats.org/drawingml/2006/main"/>
           <a:p xmlns:a="http://schemas.openxmlformats.org/drawingml/2006/main">
             <a:pPr algn="l">
+              <a:buNone/>
               <a:defRPr sz="1875" b="1">
                 <a:solidFill>
                   <a:srgbClr val="0B0B12"/>
@@ -2483,7 +3035,7 @@
                 <a:ea typeface="Arial"/>
                 <a:cs typeface="Arial"/>
               </a:rPr>
-              <a:t>Has this person already claimed here?</a:t>
+              <a:t>Has this claimant secret claimed here?</a:t>
             </a:r>
           </a:p>
         </p:txBody>
@@ -2523,6 +3075,7 @@
           <a:lstStyle xmlns:a="http://schemas.openxmlformats.org/drawingml/2006/main"/>
           <a:p xmlns:a="http://schemas.openxmlformats.org/drawingml/2006/main">
             <a:pPr algn="l">
+              <a:buNone/>
               <a:defRPr sz="4050" b="1">
                 <a:solidFill>
                   <a:srgbClr val="2D9CDB"/>
@@ -2581,6 +3134,7 @@
           <a:lstStyle xmlns:a="http://schemas.openxmlformats.org/drawingml/2006/main"/>
           <a:p xmlns:a="http://schemas.openxmlformats.org/drawingml/2006/main">
             <a:pPr algn="l">
+              <a:buNone/>
               <a:defRPr sz="1875" b="1">
                 <a:solidFill>
                   <a:srgbClr val="0B0B12"/>
@@ -2672,6 +3226,7 @@
           <a:lstStyle xmlns:a="http://schemas.openxmlformats.org/drawingml/2006/main"/>
           <a:p xmlns:a="http://schemas.openxmlformats.org/drawingml/2006/main">
             <a:pPr algn="l">
+              <a:buNone/>
               <a:defRPr sz="1425" b="1">
                 <a:solidFill>
                   <a:srgbClr val="B9B6FF"/>
@@ -2730,6 +3285,7 @@
           <a:lstStyle xmlns:a="http://schemas.openxmlformats.org/drawingml/2006/main"/>
           <a:p xmlns:a="http://schemas.openxmlformats.org/drawingml/2006/main">
             <a:pPr algn="l">
+              <a:buNone/>
               <a:defRPr sz="2550" b="1">
                 <a:solidFill>
                   <a:srgbClr val="FFFFFF"/>
@@ -2753,6 +3309,7 @@
           </a:p>
           <a:p xmlns:a="http://schemas.openxmlformats.org/drawingml/2006/main">
             <a:pPr algn="l">
+              <a:buNone/>
               <a:defRPr sz="2550" b="1">
                 <a:solidFill>
                   <a:srgbClr val="FFFFFF"/>
@@ -2776,6 +3333,7 @@
           </a:p>
           <a:p xmlns:a="http://schemas.openxmlformats.org/drawingml/2006/main">
             <a:pPr algn="l">
+              <a:buNone/>
               <a:defRPr sz="2550" b="1">
                 <a:solidFill>
                   <a:srgbClr val="FFFFFF"/>
@@ -2834,6 +3392,7 @@
           <a:lstStyle xmlns:a="http://schemas.openxmlformats.org/drawingml/2006/main"/>
           <a:p xmlns:a="http://schemas.openxmlformats.org/drawingml/2006/main">
             <a:pPr algn="l">
+              <a:buNone/>
               <a:defRPr sz="1575" b="0">
                 <a:solidFill>
                   <a:srgbClr val="FFFFFF"/>
@@ -2921,6 +3480,7 @@
           <a:lstStyle xmlns:a="http://schemas.openxmlformats.org/drawingml/2006/main"/>
           <a:p xmlns:a="http://schemas.openxmlformats.org/drawingml/2006/main">
             <a:pPr algn="l">
+              <a:buNone/>
               <a:defRPr sz="1125" b="1">
                 <a:solidFill>
                   <a:srgbClr val="6257F5"/>
@@ -2979,6 +3539,7 @@
           <a:lstStyle xmlns:a="http://schemas.openxmlformats.org/drawingml/2006/main"/>
           <a:p xmlns:a="http://schemas.openxmlformats.org/drawingml/2006/main">
             <a:pPr algn="l">
+              <a:buNone/>
               <a:defRPr sz="3150" b="1">
                 <a:solidFill>
                   <a:srgbClr val="0B0B12"/>
@@ -3037,6 +3598,7 @@
           <a:lstStyle xmlns:a="http://schemas.openxmlformats.org/drawingml/2006/main"/>
           <a:p xmlns:a="http://schemas.openxmlformats.org/drawingml/2006/main">
             <a:pPr algn="r">
+              <a:buNone/>
               <a:defRPr sz="975" b="0">
                 <a:solidFill>
                   <a:srgbClr val="5E6270"/>
@@ -3128,6 +3690,7 @@
           <a:lstStyle xmlns:a="http://schemas.openxmlformats.org/drawingml/2006/main"/>
           <a:p xmlns:a="http://schemas.openxmlformats.org/drawingml/2006/main">
             <a:pPr algn="l">
+              <a:buNone/>
               <a:defRPr sz="2925" b="1">
                 <a:solidFill>
                   <a:srgbClr val="5E6270"/>
@@ -3186,6 +3749,7 @@
           <a:lstStyle xmlns:a="http://schemas.openxmlformats.org/drawingml/2006/main"/>
           <a:p xmlns:a="http://schemas.openxmlformats.org/drawingml/2006/main">
             <a:pPr algn="l">
+              <a:buNone/>
               <a:defRPr sz="1350" b="1">
                 <a:solidFill>
                   <a:srgbClr val="6257F5"/>
@@ -3244,6 +3808,7 @@
           <a:lstStyle xmlns:a="http://schemas.openxmlformats.org/drawingml/2006/main"/>
           <a:p xmlns:a="http://schemas.openxmlformats.org/drawingml/2006/main">
             <a:pPr algn="l">
+              <a:buNone/>
               <a:defRPr sz="1800" b="1">
                 <a:solidFill>
                   <a:srgbClr val="0B0B12"/>
@@ -3335,6 +3900,7 @@
           <a:lstStyle xmlns:a="http://schemas.openxmlformats.org/drawingml/2006/main"/>
           <a:p xmlns:a="http://schemas.openxmlformats.org/drawingml/2006/main">
             <a:pPr algn="l">
+              <a:buNone/>
               <a:defRPr sz="2925" b="1">
                 <a:solidFill>
                   <a:srgbClr val="6257F5"/>
@@ -3393,6 +3959,7 @@
           <a:lstStyle xmlns:a="http://schemas.openxmlformats.org/drawingml/2006/main"/>
           <a:p xmlns:a="http://schemas.openxmlformats.org/drawingml/2006/main">
             <a:pPr algn="l">
+              <a:buNone/>
               <a:defRPr sz="1350" b="1">
                 <a:solidFill>
                   <a:srgbClr val="6257F5"/>
@@ -3451,6 +4018,7 @@
           <a:lstStyle xmlns:a="http://schemas.openxmlformats.org/drawingml/2006/main"/>
           <a:p xmlns:a="http://schemas.openxmlformats.org/drawingml/2006/main">
             <a:pPr algn="l">
+              <a:buNone/>
               <a:defRPr sz="1800" b="1">
                 <a:solidFill>
                   <a:srgbClr val="0B0B12"/>
@@ -3542,6 +4110,7 @@
           <a:lstStyle xmlns:a="http://schemas.openxmlformats.org/drawingml/2006/main"/>
           <a:p xmlns:a="http://schemas.openxmlformats.org/drawingml/2006/main">
             <a:pPr algn="l">
+              <a:buNone/>
               <a:defRPr sz="2925" b="1">
                 <a:solidFill>
                   <a:srgbClr val="5E6270"/>
@@ -3600,6 +4169,7 @@
           <a:lstStyle xmlns:a="http://schemas.openxmlformats.org/drawingml/2006/main"/>
           <a:p xmlns:a="http://schemas.openxmlformats.org/drawingml/2006/main">
             <a:pPr algn="l">
+              <a:buNone/>
               <a:defRPr sz="1350" b="1">
                 <a:solidFill>
                   <a:srgbClr val="6257F5"/>
@@ -3658,6 +4228,7 @@
           <a:lstStyle xmlns:a="http://schemas.openxmlformats.org/drawingml/2006/main"/>
           <a:p xmlns:a="http://schemas.openxmlformats.org/drawingml/2006/main">
             <a:pPr algn="l">
+              <a:buNone/>
               <a:defRPr sz="1800" b="1">
                 <a:solidFill>
                   <a:srgbClr val="0B0B12"/>
@@ -3676,7 +4247,7 @@
                 <a:ea typeface="Arial"/>
                 <a:cs typeface="Arial"/>
               </a:rPr>
-              <a:t>Used nullifier, capped inventory, transaction evidence</a:t>
+              <a:t>Used nullifier, program outcome, transaction evidence</a:t>
             </a:r>
           </a:p>
         </p:txBody>
@@ -3716,6 +4287,7 @@
           <a:lstStyle xmlns:a="http://schemas.openxmlformats.org/drawingml/2006/main"/>
           <a:p xmlns:a="http://schemas.openxmlformats.org/drawingml/2006/main">
             <a:pPr algn="ctr">
+              <a:buNone/>
               <a:defRPr sz="2700" b="1">
                 <a:solidFill>
                   <a:srgbClr val="6257F5"/>
@@ -3774,6 +4346,7 @@
           <a:lstStyle xmlns:a="http://schemas.openxmlformats.org/drawingml/2006/main"/>
           <a:p xmlns:a="http://schemas.openxmlformats.org/drawingml/2006/main">
             <a:pPr algn="ctr">
+              <a:buNone/>
               <a:defRPr sz="2700" b="1">
                 <a:solidFill>
                   <a:srgbClr val="6257F5"/>
@@ -3861,6 +4434,7 @@
           <a:lstStyle xmlns:a="http://schemas.openxmlformats.org/drawingml/2006/main"/>
           <a:p xmlns:a="http://schemas.openxmlformats.org/drawingml/2006/main">
             <a:pPr algn="l">
+              <a:buNone/>
               <a:defRPr sz="1125" b="1">
                 <a:solidFill>
                   <a:srgbClr val="6257F5"/>
@@ -3919,6 +4493,7 @@
           <a:lstStyle xmlns:a="http://schemas.openxmlformats.org/drawingml/2006/main"/>
           <a:p xmlns:a="http://schemas.openxmlformats.org/drawingml/2006/main">
             <a:pPr algn="l">
+              <a:buNone/>
               <a:defRPr sz="3150" b="1">
                 <a:solidFill>
                   <a:srgbClr val="0B0B12"/>
@@ -3977,6 +4552,7 @@
           <a:lstStyle xmlns:a="http://schemas.openxmlformats.org/drawingml/2006/main"/>
           <a:p xmlns:a="http://schemas.openxmlformats.org/drawingml/2006/main">
             <a:pPr algn="r">
+              <a:buNone/>
               <a:defRPr sz="975" b="0">
                 <a:solidFill>
                   <a:srgbClr val="5E6270"/>
@@ -4101,6 +4677,7 @@
           <a:lstStyle xmlns:a="http://schemas.openxmlformats.org/drawingml/2006/main"/>
           <a:p xmlns:a="http://schemas.openxmlformats.org/drawingml/2006/main">
             <a:pPr algn="l">
+              <a:buNone/>
               <a:defRPr sz="1350" b="1">
                 <a:solidFill>
                   <a:srgbClr val="B9B6FF"/>
@@ -4159,6 +4736,7 @@
           <a:lstStyle xmlns:a="http://schemas.openxmlformats.org/drawingml/2006/main"/>
           <a:p xmlns:a="http://schemas.openxmlformats.org/drawingml/2006/main">
             <a:pPr algn="l">
+              <a:buNone/>
               <a:defRPr sz="2175" b="1">
                 <a:solidFill>
                   <a:srgbClr val="FFFFFF"/>
@@ -4182,6 +4760,7 @@
           </a:p>
           <a:p xmlns:a="http://schemas.openxmlformats.org/drawingml/2006/main">
             <a:pPr algn="l">
+              <a:buNone/>
               <a:defRPr sz="2175" b="1">
                 <a:solidFill>
                   <a:srgbClr val="FFFFFF"/>
@@ -4200,11 +4779,12 @@
                 <a:ea typeface="Arial"/>
                 <a:cs typeface="Arial"/>
               </a:rPr>
-              <a:t>• Eligibility answers</a:t>
-            </a:r>
-          </a:p>
-          <a:p xmlns:a="http://schemas.openxmlformats.org/drawingml/2006/main">
-            <a:pPr algn="l">
+              <a:t>• Eligibility values</a:t>
+            </a:r>
+          </a:p>
+          <a:p xmlns:a="http://schemas.openxmlformats.org/drawingml/2006/main">
+            <a:pPr algn="l">
+              <a:buNone/>
               <a:defRPr sz="2175" b="1">
                 <a:solidFill>
                   <a:srgbClr val="FFFFFF"/>
@@ -4228,6 +4808,7 @@
           </a:p>
           <a:p xmlns:a="http://schemas.openxmlformats.org/drawingml/2006/main">
             <a:pPr algn="l">
+              <a:buNone/>
               <a:defRPr sz="2175" b="1">
                 <a:solidFill>
                   <a:srgbClr val="FFFFFF"/>
@@ -4246,7 +4827,7 @@
                 <a:ea typeface="Arial"/>
                 <a:cs typeface="Arial"/>
               </a:rPr>
-              <a:t>• Cross-program identity</a:t>
+              <a:t>• Subject binding</a:t>
             </a:r>
           </a:p>
         </p:txBody>
@@ -4286,6 +4867,7 @@
           <a:lstStyle xmlns:a="http://schemas.openxmlformats.org/drawingml/2006/main"/>
           <a:p xmlns:a="http://schemas.openxmlformats.org/drawingml/2006/main">
             <a:pPr algn="l">
+              <a:buNone/>
               <a:defRPr sz="1350" b="1">
                 <a:solidFill>
                   <a:srgbClr val="6257F5"/>
@@ -4344,6 +4926,7 @@
           <a:lstStyle xmlns:a="http://schemas.openxmlformats.org/drawingml/2006/main"/>
           <a:p xmlns:a="http://schemas.openxmlformats.org/drawingml/2006/main">
             <a:pPr algn="l">
+              <a:buNone/>
               <a:defRPr sz="2175" b="1">
                 <a:solidFill>
                   <a:srgbClr val="0B0B12"/>
@@ -4367,6 +4950,7 @@
           </a:p>
           <a:p xmlns:a="http://schemas.openxmlformats.org/drawingml/2006/main">
             <a:pPr algn="l">
+              <a:buNone/>
               <a:defRPr sz="2175" b="1">
                 <a:solidFill>
                   <a:srgbClr val="0B0B12"/>
@@ -4385,11 +4969,12 @@
                 <a:ea typeface="Arial"/>
                 <a:cs typeface="Arial"/>
               </a:rPr>
-              <a:t>• Remaining inventory</a:t>
-            </a:r>
-          </a:p>
-          <a:p xmlns:a="http://schemas.openxmlformats.org/drawingml/2006/main">
-            <a:pPr algn="l">
+              <a:t>• Successful program outcome</a:t>
+            </a:r>
+          </a:p>
+          <a:p xmlns:a="http://schemas.openxmlformats.org/drawingml/2006/main">
+            <a:pPr algn="l">
+              <a:buNone/>
               <a:defRPr sz="2175" b="1">
                 <a:solidFill>
                   <a:srgbClr val="0B0B12"/>
@@ -4408,11 +4993,12 @@
                 <a:ea typeface="Arial"/>
                 <a:cs typeface="Arial"/>
               </a:rPr>
-              <a:t>• Policy metadata</a:t>
-            </a:r>
-          </a:p>
-          <a:p xmlns:a="http://schemas.openxmlformats.org/drawingml/2006/main">
-            <a:pPr algn="l">
+              <a:t>• Issuer and policy metadata</a:t>
+            </a:r>
+          </a:p>
+          <a:p xmlns:a="http://schemas.openxmlformats.org/drawingml/2006/main">
+            <a:pPr algn="l">
+              <a:buNone/>
               <a:defRPr sz="2175" b="1">
                 <a:solidFill>
                   <a:srgbClr val="0B0B12"/>
@@ -4431,7 +5017,7 @@
                 <a:ea typeface="Arial"/>
                 <a:cs typeface="Arial"/>
               </a:rPr>
-              <a:t>• Receipt and chain evidence</a:t>
+              <a:t>• Scoped revocation handle</a:t>
             </a:r>
           </a:p>
         </p:txBody>
@@ -4471,6 +5057,7 @@
           <a:lstStyle xmlns:a="http://schemas.openxmlformats.org/drawingml/2006/main"/>
           <a:p xmlns:a="http://schemas.openxmlformats.org/drawingml/2006/main">
             <a:pPr algn="ctr">
+              <a:buNone/>
               <a:defRPr sz="1725" b="1">
                 <a:solidFill>
                   <a:srgbClr val="6257F5"/>
@@ -4558,6 +5145,7 @@
           <a:lstStyle xmlns:a="http://schemas.openxmlformats.org/drawingml/2006/main"/>
           <a:p xmlns:a="http://schemas.openxmlformats.org/drawingml/2006/main">
             <a:pPr algn="l">
+              <a:buNone/>
               <a:defRPr sz="1125" b="1">
                 <a:solidFill>
                   <a:srgbClr val="6257F5"/>
@@ -4616,6 +5204,7 @@
           <a:lstStyle xmlns:a="http://schemas.openxmlformats.org/drawingml/2006/main"/>
           <a:p xmlns:a="http://schemas.openxmlformats.org/drawingml/2006/main">
             <a:pPr algn="l">
+              <a:buNone/>
               <a:defRPr sz="3150" b="1">
                 <a:solidFill>
                   <a:srgbClr val="0B0B12"/>
@@ -4674,6 +5263,7 @@
           <a:lstStyle xmlns:a="http://schemas.openxmlformats.org/drawingml/2006/main"/>
           <a:p xmlns:a="http://schemas.openxmlformats.org/drawingml/2006/main">
             <a:pPr algn="r">
+              <a:buNone/>
               <a:defRPr sz="975" b="0">
                 <a:solidFill>
                   <a:srgbClr val="5E6270"/>
@@ -4765,6 +5355,7 @@
           <a:lstStyle xmlns:a="http://schemas.openxmlformats.org/drawingml/2006/main"/>
           <a:p xmlns:a="http://schemas.openxmlformats.org/drawingml/2006/main">
             <a:pPr algn="l">
+              <a:buNone/>
               <a:defRPr sz="2850" b="1">
                 <a:solidFill>
                   <a:srgbClr val="6257F5"/>
@@ -4823,6 +5414,7 @@
           <a:lstStyle xmlns:a="http://schemas.openxmlformats.org/drawingml/2006/main"/>
           <a:p xmlns:a="http://schemas.openxmlformats.org/drawingml/2006/main">
             <a:pPr algn="l">
+              <a:buNone/>
               <a:defRPr sz="1875" b="1">
                 <a:solidFill>
                   <a:srgbClr val="0B0B12"/>
@@ -4881,6 +5473,7 @@
           <a:lstStyle xmlns:a="http://schemas.openxmlformats.org/drawingml/2006/main"/>
           <a:p xmlns:a="http://schemas.openxmlformats.org/drawingml/2006/main">
             <a:pPr algn="l">
+              <a:buNone/>
               <a:defRPr sz="1425" b="0">
                 <a:solidFill>
                   <a:srgbClr val="5E6270"/>
@@ -4899,7 +5492,7 @@
                 <a:ea typeface="Arial"/>
                 <a:cs typeface="Arial"/>
               </a:rPr>
-              <a:t>Any enabled Connector API v4 wallet</a:t>
+              <a:t>Compatible v4 wallet; tested with 1AM</a:t>
             </a:r>
           </a:p>
         </p:txBody>
@@ -4972,6 +5565,7 @@
           <a:lstStyle xmlns:a="http://schemas.openxmlformats.org/drawingml/2006/main"/>
           <a:p xmlns:a="http://schemas.openxmlformats.org/drawingml/2006/main">
             <a:pPr algn="l">
+              <a:buNone/>
               <a:defRPr sz="2850" b="1">
                 <a:solidFill>
                   <a:srgbClr val="6257F5"/>
@@ -5030,6 +5624,7 @@
           <a:lstStyle xmlns:a="http://schemas.openxmlformats.org/drawingml/2006/main"/>
           <a:p xmlns:a="http://schemas.openxmlformats.org/drawingml/2006/main">
             <a:pPr algn="l">
+              <a:buNone/>
               <a:defRPr sz="1875" b="1">
                 <a:solidFill>
                   <a:srgbClr val="0B0B12"/>
@@ -5088,6 +5683,7 @@
           <a:lstStyle xmlns:a="http://schemas.openxmlformats.org/drawingml/2006/main"/>
           <a:p xmlns:a="http://schemas.openxmlformats.org/drawingml/2006/main">
             <a:pPr algn="l">
+              <a:buNone/>
               <a:defRPr sz="1425" b="0">
                 <a:solidFill>
                   <a:srgbClr val="5E6270"/>
@@ -5179,6 +5775,7 @@
           <a:lstStyle xmlns:a="http://schemas.openxmlformats.org/drawingml/2006/main"/>
           <a:p xmlns:a="http://schemas.openxmlformats.org/drawingml/2006/main">
             <a:pPr algn="l">
+              <a:buNone/>
               <a:defRPr sz="2850" b="1">
                 <a:solidFill>
                   <a:srgbClr val="6257F5"/>
@@ -5237,6 +5834,7 @@
           <a:lstStyle xmlns:a="http://schemas.openxmlformats.org/drawingml/2006/main"/>
           <a:p xmlns:a="http://schemas.openxmlformats.org/drawingml/2006/main">
             <a:pPr algn="l">
+              <a:buNone/>
               <a:defRPr sz="1875" b="1">
                 <a:solidFill>
                   <a:srgbClr val="0B0B12"/>
@@ -5295,6 +5893,7 @@
           <a:lstStyle xmlns:a="http://schemas.openxmlformats.org/drawingml/2006/main"/>
           <a:p xmlns:a="http://schemas.openxmlformats.org/drawingml/2006/main">
             <a:pPr algn="l">
+              <a:buNone/>
               <a:defRPr sz="1425" b="0">
                 <a:solidFill>
                   <a:srgbClr val="5E6270"/>
@@ -5313,7 +5912,7 @@
                 <a:ea typeface="Arial"/>
                 <a:cs typeface="Arial"/>
               </a:rPr>
-              <a:t>Receive a signed eligibility credential</a:t>
+              <a:t>Receive a signed test credential</a:t>
             </a:r>
           </a:p>
         </p:txBody>
@@ -5386,6 +5985,7 @@
           <a:lstStyle xmlns:a="http://schemas.openxmlformats.org/drawingml/2006/main"/>
           <a:p xmlns:a="http://schemas.openxmlformats.org/drawingml/2006/main">
             <a:pPr algn="l">
+              <a:buNone/>
               <a:defRPr sz="2850" b="1">
                 <a:solidFill>
                   <a:srgbClr val="6257F5"/>
@@ -5444,6 +6044,7 @@
           <a:lstStyle xmlns:a="http://schemas.openxmlformats.org/drawingml/2006/main"/>
           <a:p xmlns:a="http://schemas.openxmlformats.org/drawingml/2006/main">
             <a:pPr algn="l">
+              <a:buNone/>
               <a:defRPr sz="1875" b="1">
                 <a:solidFill>
                   <a:srgbClr val="0B0B12"/>
@@ -5502,6 +6103,7 @@
           <a:lstStyle xmlns:a="http://schemas.openxmlformats.org/drawingml/2006/main"/>
           <a:p xmlns:a="http://schemas.openxmlformats.org/drawingml/2006/main">
             <a:pPr algn="l">
+              <a:buNone/>
               <a:defRPr sz="1425" b="0">
                 <a:solidFill>
                   <a:srgbClr val="5E6270"/>
@@ -5520,7 +6122,7 @@
                 <a:ea typeface="Arial"/>
                 <a:cs typeface="Arial"/>
               </a:rPr>
-              <a:t>Prove eligibility and reserve inventory</a:t>
+              <a:t>Approve a private Preprod claim</a:t>
             </a:r>
           </a:p>
         </p:txBody>
@@ -5593,6 +6195,7 @@
           <a:lstStyle xmlns:a="http://schemas.openxmlformats.org/drawingml/2006/main"/>
           <a:p xmlns:a="http://schemas.openxmlformats.org/drawingml/2006/main">
             <a:pPr algn="l">
+              <a:buNone/>
               <a:defRPr sz="2850" b="1">
                 <a:solidFill>
                   <a:srgbClr val="6257F5"/>
@@ -5651,6 +6254,7 @@
           <a:lstStyle xmlns:a="http://schemas.openxmlformats.org/drawingml/2006/main"/>
           <a:p xmlns:a="http://schemas.openxmlformats.org/drawingml/2006/main">
             <a:pPr algn="l">
+              <a:buNone/>
               <a:defRPr sz="1875" b="1">
                 <a:solidFill>
                   <a:srgbClr val="0B0B12"/>
@@ -5669,7 +6273,7 @@
                 <a:ea typeface="Arial"/>
                 <a:cs typeface="Arial"/>
               </a:rPr>
-              <a:t>Reject</a:t>
+              <a:t>Verify</a:t>
             </a:r>
           </a:p>
         </p:txBody>
@@ -5709,6 +6313,7 @@
           <a:lstStyle xmlns:a="http://schemas.openxmlformats.org/drawingml/2006/main"/>
           <a:p xmlns:a="http://schemas.openxmlformats.org/drawingml/2006/main">
             <a:pPr algn="l">
+              <a:buNone/>
               <a:defRPr sz="1425" b="0">
                 <a:solidFill>
                   <a:srgbClr val="5E6270"/>
@@ -5727,21 +6332,21 @@
                 <a:ea typeface="Arial"/>
                 <a:cs typeface="Arial"/>
               </a:rPr>
-              <a:t>Retry the program and see duplicate protection</a:t>
+              <a:t>Inspect the confirmed transaction and state</a:t>
             </a:r>
           </a:p>
         </p:txBody>
       </p:sp>
       <p:pic>
         <p:nvPicPr>
-          <p:cNvPr id="49" name=""/>
+          <p:cNvPr id="51" name=""/>
           <p:cNvPicPr>
             <a:picLocks xmlns:a="http://schemas.openxmlformats.org/drawingml/2006/main" noChangeAspect="1"/>
           </p:cNvPicPr>
           <p:nvPr/>
         </p:nvPicPr>
         <p:blipFill>
-          <a:blip xmlns:r="http://schemas.openxmlformats.org/officeDocument/2006/relationships" xmlns:a="http://schemas.openxmlformats.org/drawingml/2006/main" r:embed="Rb172d5bf848e4615"/>
+          <a:blip xmlns:r="http://schemas.openxmlformats.org/officeDocument/2006/relationships" xmlns:a="http://schemas.openxmlformats.org/drawingml/2006/main" r:embed="Rf0bd6ce5d1024b71"/>
           <a:stretch xmlns:a="http://schemas.openxmlformats.org/drawingml/2006/main"/>
         </p:blipFill>
         <p:spPr>
@@ -5789,6 +6394,7 @@
           <a:lstStyle xmlns:a="http://schemas.openxmlformats.org/drawingml/2006/main"/>
           <a:p xmlns:a="http://schemas.openxmlformats.org/drawingml/2006/main">
             <a:pPr algn="l">
+              <a:buNone/>
               <a:defRPr sz="1500" b="1">
                 <a:solidFill>
                   <a:srgbClr val="6257F5"/>
@@ -5807,7 +6413,7 @@
                 <a:ea typeface="Arial"/>
                 <a:cs typeface="Arial"/>
               </a:rPr>
-              <a:t>Live product: aletheia-pi.vercel.app</a:t>
+              <a:t>Live product: alethia-pi.vercel.app</a:t>
             </a:r>
           </a:p>
         </p:txBody>
@@ -5876,6 +6482,7 @@
           <a:lstStyle xmlns:a="http://schemas.openxmlformats.org/drawingml/2006/main"/>
           <a:p xmlns:a="http://schemas.openxmlformats.org/drawingml/2006/main">
             <a:pPr algn="l">
+              <a:buNone/>
               <a:defRPr sz="1125" b="1">
                 <a:solidFill>
                   <a:srgbClr val="6257F5"/>
@@ -5934,6 +6541,7 @@
           <a:lstStyle xmlns:a="http://schemas.openxmlformats.org/drawingml/2006/main"/>
           <a:p xmlns:a="http://schemas.openxmlformats.org/drawingml/2006/main">
             <a:pPr algn="l">
+              <a:buNone/>
               <a:defRPr sz="3150" b="1">
                 <a:solidFill>
                   <a:srgbClr val="0B0B12"/>
@@ -5992,6 +6600,7 @@
           <a:lstStyle xmlns:a="http://schemas.openxmlformats.org/drawingml/2006/main"/>
           <a:p xmlns:a="http://schemas.openxmlformats.org/drawingml/2006/main">
             <a:pPr algn="r">
+              <a:buNone/>
               <a:defRPr sz="975" b="0">
                 <a:solidFill>
                   <a:srgbClr val="5E6270"/>
@@ -6045,11 +6654,12 @@
         </p:spPr>
         <p:txBody>
           <a:bodyPr xmlns:a="http://schemas.openxmlformats.org/drawingml/2006/main" anchor="t">
-            <a:normAutofit fontScale="99233"/>
+            <a:normAutofit fontScale="100000"/>
           </a:bodyPr>
           <a:lstStyle xmlns:a="http://schemas.openxmlformats.org/drawingml/2006/main"/>
           <a:p xmlns:a="http://schemas.openxmlformats.org/drawingml/2006/main">
             <a:pPr algn="l">
+              <a:buNone/>
               <a:defRPr sz="1725" b="0">
                 <a:solidFill>
                   <a:srgbClr val="5E6270"/>
@@ -6068,7 +6678,7 @@
                 <a:ea typeface="Arial"/>
                 <a:cs typeface="Arial"/>
               </a:rPr>
-              <a:t>The work centered on qualification, privacy guarantees, wallet compatibility, and evidence—not feature sprawl.</a:t>
+              <a:t>Wave 1 added real Preprod execution, encrypted recovery, wallet compatibility and reproducible tests.</a:t>
             </a:r>
           </a:p>
         </p:txBody>
@@ -6141,6 +6751,7 @@
           <a:lstStyle xmlns:a="http://schemas.openxmlformats.org/drawingml/2006/main"/>
           <a:p xmlns:a="http://schemas.openxmlformats.org/drawingml/2006/main">
             <a:pPr algn="l">
+              <a:buNone/>
               <a:defRPr sz="4800" b="1">
                 <a:solidFill>
                   <a:srgbClr val="6257F5"/>
@@ -6159,7 +6770,7 @@
                 <a:ea typeface="Arial"/>
                 <a:cs typeface="Arial"/>
               </a:rPr>
-              <a:t>22</a:t>
+              <a:t>64</a:t>
             </a:r>
           </a:p>
         </p:txBody>
@@ -6199,6 +6810,7 @@
           <a:lstStyle xmlns:a="http://schemas.openxmlformats.org/drawingml/2006/main"/>
           <a:p xmlns:a="http://schemas.openxmlformats.org/drawingml/2006/main">
             <a:pPr algn="l">
+              <a:buNone/>
               <a:defRPr sz="1725" b="1">
                 <a:solidFill>
                   <a:srgbClr val="0B0B12"/>
@@ -6290,6 +6902,7 @@
           <a:lstStyle xmlns:a="http://schemas.openxmlformats.org/drawingml/2006/main"/>
           <a:p xmlns:a="http://schemas.openxmlformats.org/drawingml/2006/main">
             <a:pPr algn="l">
+              <a:buNone/>
               <a:defRPr sz="4800" b="1">
                 <a:solidFill>
                   <a:srgbClr val="0B0B12"/>
@@ -6348,6 +6961,7 @@
           <a:lstStyle xmlns:a="http://schemas.openxmlformats.org/drawingml/2006/main"/>
           <a:p xmlns:a="http://schemas.openxmlformats.org/drawingml/2006/main">
             <a:pPr algn="l">
+              <a:buNone/>
               <a:defRPr sz="1725" b="1">
                 <a:solidFill>
                   <a:srgbClr val="0B0B12"/>
@@ -6366,7 +6980,7 @@
                 <a:ea typeface="Arial"/>
                 <a:cs typeface="Arial"/>
               </a:rPr>
-              <a:t>production audit vulnerabilities</a:t>
+              <a:t>known production dependency advisories</a:t>
             </a:r>
           </a:p>
         </p:txBody>
@@ -6439,6 +7053,7 @@
           <a:lstStyle xmlns:a="http://schemas.openxmlformats.org/drawingml/2006/main"/>
           <a:p xmlns:a="http://schemas.openxmlformats.org/drawingml/2006/main">
             <a:pPr algn="l">
+              <a:buNone/>
               <a:defRPr sz="4800" b="1">
                 <a:solidFill>
                   <a:srgbClr val="0B0B12"/>
@@ -6497,6 +7112,7 @@
           <a:lstStyle xmlns:a="http://schemas.openxmlformats.org/drawingml/2006/main"/>
           <a:p xmlns:a="http://schemas.openxmlformats.org/drawingml/2006/main">
             <a:pPr algn="l">
+              <a:buNone/>
               <a:defRPr sz="1725" b="1">
                 <a:solidFill>
                   <a:srgbClr val="0B0B12"/>
@@ -6515,7 +7131,7 @@
                 <a:ea typeface="Arial"/>
                 <a:cs typeface="Arial"/>
               </a:rPr>
-              <a:t>compiling Compact contract</a:t>
+              <a:t>confirmed Preprod claim</a:t>
             </a:r>
           </a:p>
         </p:txBody>
@@ -6584,6 +7200,7 @@
           <a:lstStyle xmlns:a="http://schemas.openxmlformats.org/drawingml/2006/main"/>
           <a:p xmlns:a="http://schemas.openxmlformats.org/drawingml/2006/main">
             <a:pPr algn="l">
+              <a:buNone/>
               <a:defRPr sz="1125" b="1">
                 <a:solidFill>
                   <a:srgbClr val="6257F5"/>
@@ -6637,11 +7254,12 @@
         </p:spPr>
         <p:txBody>
           <a:bodyPr xmlns:a="http://schemas.openxmlformats.org/drawingml/2006/main" anchor="t">
-            <a:normAutofit fontScale="86432"/>
+            <a:normAutofit fontScale="100000"/>
           </a:bodyPr>
           <a:lstStyle xmlns:a="http://schemas.openxmlformats.org/drawingml/2006/main"/>
           <a:p xmlns:a="http://schemas.openxmlformats.org/drawingml/2006/main">
             <a:pPr algn="l">
+              <a:buNone/>
               <a:defRPr sz="3150" b="1">
                 <a:solidFill>
                   <a:srgbClr val="0B0B12"/>
@@ -6660,7 +7278,7 @@
                 <a:ea typeface="Arial"/>
                 <a:cs typeface="Arial"/>
               </a:rPr>
-              <a:t>The implementation is verifiable; Preprod evidence is the next gate.</a:t>
+              <a:t>A live claim is confirmed on Midnight Preprod.</a:t>
             </a:r>
           </a:p>
         </p:txBody>
@@ -6700,6 +7318,7 @@
           <a:lstStyle xmlns:a="http://schemas.openxmlformats.org/drawingml/2006/main"/>
           <a:p xmlns:a="http://schemas.openxmlformats.org/drawingml/2006/main">
             <a:pPr algn="r">
+              <a:buNone/>
               <a:defRPr sz="975" b="0">
                 <a:solidFill>
                   <a:srgbClr val="5E6270"/>
@@ -6758,6 +7377,7 @@
           <a:lstStyle xmlns:a="http://schemas.openxmlformats.org/drawingml/2006/main"/>
           <a:p xmlns:a="http://schemas.openxmlformats.org/drawingml/2006/main">
             <a:pPr algn="l">
+              <a:buNone/>
               <a:defRPr sz="1350" b="1">
                 <a:solidFill>
                   <a:srgbClr val="146C43"/>
@@ -6816,6 +7436,7 @@
           <a:lstStyle xmlns:a="http://schemas.openxmlformats.org/drawingml/2006/main"/>
           <a:p xmlns:a="http://schemas.openxmlformats.org/drawingml/2006/main">
             <a:pPr algn="l">
+              <a:buNone/>
               <a:defRPr sz="1875" b="1">
                 <a:solidFill>
                   <a:srgbClr val="0B0B12"/>
@@ -6839,6 +7460,7 @@
           </a:p>
           <a:p xmlns:a="http://schemas.openxmlformats.org/drawingml/2006/main">
             <a:pPr algn="l">
+              <a:buNone/>
               <a:defRPr sz="1875" b="1">
                 <a:solidFill>
                   <a:srgbClr val="0B0B12"/>
@@ -6862,6 +7484,7 @@
           </a:p>
           <a:p xmlns:a="http://schemas.openxmlformats.org/drawingml/2006/main">
             <a:pPr algn="l">
+              <a:buNone/>
               <a:defRPr sz="1875" b="1">
                 <a:solidFill>
                   <a:srgbClr val="0B0B12"/>
@@ -6885,6 +7508,7 @@
           </a:p>
           <a:p xmlns:a="http://schemas.openxmlformats.org/drawingml/2006/main">
             <a:pPr algn="l">
+              <a:buNone/>
               <a:defRPr sz="1875" b="1">
                 <a:solidFill>
                   <a:srgbClr val="0B0B12"/>
@@ -6908,6 +7532,7 @@
           </a:p>
           <a:p xmlns:a="http://schemas.openxmlformats.org/drawingml/2006/main">
             <a:pPr algn="l">
+              <a:buNone/>
               <a:defRPr sz="1875" b="1">
                 <a:solidFill>
                   <a:srgbClr val="0B0B12"/>
@@ -6999,6 +7624,7 @@
           <a:lstStyle xmlns:a="http://schemas.openxmlformats.org/drawingml/2006/main"/>
           <a:p xmlns:a="http://schemas.openxmlformats.org/drawingml/2006/main">
             <a:pPr algn="l">
+              <a:buNone/>
               <a:defRPr sz="1350" b="1">
                 <a:solidFill>
                   <a:srgbClr val="B9B6FF"/>
@@ -7017,7 +7643,7 @@
                 <a:ea typeface="Arial"/>
                 <a:cs typeface="Arial"/>
               </a:rPr>
-              <a:t>NOT CLAIMED YET</a:t>
+              <a:t>CONFIRMED ON PREPROD</a:t>
             </a:r>
           </a:p>
         </p:txBody>
@@ -7057,6 +7683,7 @@
           <a:lstStyle xmlns:a="http://schemas.openxmlformats.org/drawingml/2006/main"/>
           <a:p xmlns:a="http://schemas.openxmlformats.org/drawingml/2006/main">
             <a:pPr algn="l">
+              <a:buNone/>
               <a:defRPr sz="1800" b="1">
                 <a:solidFill>
                   <a:srgbClr val="FFFFFF"/>
@@ -7075,7 +7702,8 @@
                 <a:ea typeface="Arial"/>
                 <a:cs typeface="Arial"/>
               </a:rPr>
-              <a:t>A real Preprod contract address and transaction hash require:</a:t>
+              <a:t>Food Support claim
+Block 2391682</a:t>
             </a:r>
           </a:p>
         </p:txBody>
@@ -7115,6 +7743,7 @@
           <a:lstStyle xmlns:a="http://schemas.openxmlformats.org/drawingml/2006/main"/>
           <a:p xmlns:a="http://schemas.openxmlformats.org/drawingml/2006/main">
             <a:pPr algn="l">
+              <a:buNone/>
               <a:defRPr sz="1875" b="0">
                 <a:solidFill>
                   <a:srgbClr val="FFFFFF"/>
@@ -7133,11 +7762,12 @@
                 <a:ea typeface="Arial"/>
                 <a:cs typeface="Arial"/>
               </a:rPr>
-              <a:t>• funded owner wallet</a:t>
-            </a:r>
-          </a:p>
-          <a:p xmlns:a="http://schemas.openxmlformats.org/drawingml/2006/main">
-            <a:pPr algn="l">
+              <a:t>• 1AM wallet approval</a:t>
+            </a:r>
+          </a:p>
+          <a:p xmlns:a="http://schemas.openxmlformats.org/drawingml/2006/main">
+            <a:pPr algn="l">
+              <a:buNone/>
               <a:defRPr sz="1875" b="0">
                 <a:solidFill>
                   <a:srgbClr val="FFFFFF"/>
@@ -7156,11 +7786,12 @@
                 <a:ea typeface="Arial"/>
                 <a:cs typeface="Arial"/>
               </a:rPr>
-              <a:t>• working proof path</a:t>
-            </a:r>
-          </a:p>
-          <a:p xmlns:a="http://schemas.openxmlformats.org/drawingml/2006/main">
-            <a:pPr algn="l">
+              <a:t>• Indexed successful contract call</a:t>
+            </a:r>
+          </a:p>
+          <a:p xmlns:a="http://schemas.openxmlformats.org/drawingml/2006/main">
+            <a:pPr algn="l">
+              <a:buNone/>
               <a:defRPr sz="1875" b="0">
                 <a:solidFill>
                   <a:srgbClr val="FFFFFF"/>
@@ -7179,7 +7810,7 @@
                 <a:ea typeface="Arial"/>
                 <a:cs typeface="Arial"/>
               </a:rPr>
-              <a:t>• confirmed on-chain transaction</a:t>
+              <a:t>• Matching program and nullifier</a:t>
             </a:r>
           </a:p>
         </p:txBody>
@@ -7219,6 +7850,7 @@
           <a:lstStyle xmlns:a="http://schemas.openxmlformats.org/drawingml/2006/main"/>
           <a:p xmlns:a="http://schemas.openxmlformats.org/drawingml/2006/main">
             <a:pPr algn="l">
+              <a:buNone/>
               <a:defRPr sz="1725" b="1">
                 <a:solidFill>
                   <a:srgbClr val="6257F5"/>
@@ -7237,7 +7869,7 @@
                 <a:ea typeface="Arial"/>
                 <a:cs typeface="Arial"/>
               </a:rPr>
-              <a:t>No fabricated chain evidence.</a:t>
+              <a:t>Evidence: github.com/0xNexuz/aletheia/tree/main/evidence</a:t>
             </a:r>
           </a:p>
         </p:txBody>
@@ -7306,6 +7938,7 @@
           <a:lstStyle xmlns:a="http://schemas.openxmlformats.org/drawingml/2006/main"/>
           <a:p xmlns:a="http://schemas.openxmlformats.org/drawingml/2006/main">
             <a:pPr algn="l">
+              <a:buNone/>
               <a:defRPr sz="1275" b="1">
                 <a:solidFill>
                   <a:srgbClr val="6257F5"/>
@@ -7364,6 +7997,7 @@
           <a:lstStyle xmlns:a="http://schemas.openxmlformats.org/drawingml/2006/main"/>
           <a:p xmlns:a="http://schemas.openxmlformats.org/drawingml/2006/main">
             <a:pPr algn="l">
+              <a:buNone/>
               <a:defRPr sz="5100" b="1">
                 <a:solidFill>
                   <a:srgbClr val="0B0B12"/>
@@ -7422,6 +8056,7 @@
           <a:lstStyle xmlns:a="http://schemas.openxmlformats.org/drawingml/2006/main"/>
           <a:p xmlns:a="http://schemas.openxmlformats.org/drawingml/2006/main">
             <a:pPr algn="l">
+              <a:buNone/>
               <a:defRPr sz="2250" b="1">
                 <a:solidFill>
                   <a:srgbClr val="5E6270"/>
@@ -7440,11 +8075,12 @@
                 <a:ea typeface="Arial"/>
                 <a:cs typeface="Arial"/>
               </a:rPr>
-              <a:t>Public accountability.</a:t>
-            </a:r>
-          </a:p>
-          <a:p xmlns:a="http://schemas.openxmlformats.org/drawingml/2006/main">
-            <a:pPr algn="l">
+              <a:t>Private eligibility.</a:t>
+            </a:r>
+          </a:p>
+          <a:p xmlns:a="http://schemas.openxmlformats.org/drawingml/2006/main">
+            <a:pPr algn="l">
+              <a:buNone/>
               <a:defRPr sz="2250" b="1">
                 <a:solidFill>
                   <a:srgbClr val="5E6270"/>
@@ -7463,11 +8099,12 @@
                 <a:ea typeface="Arial"/>
                 <a:cs typeface="Arial"/>
               </a:rPr>
-              <a:t>Private claimant.</a:t>
-            </a:r>
-          </a:p>
-          <a:p xmlns:a="http://schemas.openxmlformats.org/drawingml/2006/main">
-            <a:pPr algn="l">
+              <a:t>Public claim evidence.</a:t>
+            </a:r>
+          </a:p>
+          <a:p xmlns:a="http://schemas.openxmlformats.org/drawingml/2006/main">
+            <a:pPr algn="l">
+              <a:buNone/>
               <a:defRPr sz="2250" b="1">
                 <a:solidFill>
                   <a:srgbClr val="5E6270"/>
@@ -7486,7 +8123,7 @@
                 <a:ea typeface="Arial"/>
                 <a:cs typeface="Arial"/>
               </a:rPr>
-              <a:t>Verifiable limits.</a:t>
+              <a:t>Accountable issuance next.</a:t>
             </a:r>
           </a:p>
         </p:txBody>
@@ -7559,6 +8196,7 @@
           <a:lstStyle xmlns:a="http://schemas.openxmlformats.org/drawingml/2006/main"/>
           <a:p xmlns:a="http://schemas.openxmlformats.org/drawingml/2006/main">
             <a:pPr algn="l">
+              <a:buNone/>
               <a:defRPr sz="1350" b="1">
                 <a:solidFill>
                   <a:srgbClr val="6257F5"/>
@@ -7617,6 +8255,7 @@
           <a:lstStyle xmlns:a="http://schemas.openxmlformats.org/drawingml/2006/main"/>
           <a:p xmlns:a="http://schemas.openxmlformats.org/drawingml/2006/main">
             <a:pPr algn="l">
+              <a:buNone/>
               <a:defRPr sz="1800" b="1">
                 <a:solidFill>
                   <a:srgbClr val="0B0B12"/>
@@ -7635,7 +8274,7 @@
                 <a:ea typeface="Arial"/>
                 <a:cs typeface="Arial"/>
               </a:rPr>
-              <a:t>aletheia-pi.vercel.app</a:t>
+              <a:t>alethia-pi.vercel.app</a:t>
             </a:r>
           </a:p>
         </p:txBody>
@@ -7675,6 +8314,7 @@
           <a:lstStyle xmlns:a="http://schemas.openxmlformats.org/drawingml/2006/main"/>
           <a:p xmlns:a="http://schemas.openxmlformats.org/drawingml/2006/main">
             <a:pPr algn="l">
+              <a:buNone/>
               <a:defRPr sz="1275" b="0">
                 <a:solidFill>
                   <a:srgbClr val="5E6270"/>

</xml_diff>